<commit_message>
Save Canva GPS opening checkpoint before power interruption
</commit_message>
<xml_diff>
--- a/output/BACKTRACK_KEIC_2026.pptx
+++ b/output/BACKTRACK_KEIC_2026.pptx
@@ -6713,7 +6713,139 @@
       </p:grpSp>
       <p:sp>
         <p:nvSpPr>
-          <p:cNvPr name="TextBox 5" id="5"/>
+          <p:cNvPr name="Freeform 5" id="5"/>
+          <p:cNvSpPr/>
+          <p:nvPr/>
+        </p:nvSpPr>
+        <p:spPr>
+          <a:xfrm>
+            <a:off x="1714500" y="4476750"/>
+            <a:ext cx="8763000" cy="914864"/>
+          </a:xfrm>
+          <a:custGeom>
+            <a:avLst/>
+            <a:gdLst/>
+            <a:ahLst/>
+            <a:cxnLst/>
+            <a:rect r="r" b="b" t="t" l="l"/>
+            <a:pathLst>
+              <a:path h="914864" w="8763000">
+                <a:moveTo>
+                  <a:pt x="0" y="0"/>
+                </a:moveTo>
+                <a:quadBezTo>
+                  <a:pt x="4381500" y="1829728"/>
+                  <a:pt x="8763000" y="0"/>
+                </a:quadBezTo>
+              </a:path>
+            </a:pathLst>
+          </a:custGeom>
+          <a:ln cap="rnd" w="66675">
+            <a:solidFill>
+              <a:srgbClr val="C96331"/>
+            </a:solidFill>
+            <a:prstDash val="solid"/>
+            <a:headEnd type="oval" len="lg" w="lg"/>
+            <a:tailEnd type="arrow" len="sm" w="med"/>
+          </a:ln>
+        </p:spPr>
+      </p:sp>
+      <p:grpSp>
+        <p:nvGrpSpPr>
+          <p:cNvPr name="Group 6" id="6"/>
+          <p:cNvGrpSpPr/>
+          <p:nvPr/>
+        </p:nvGrpSpPr>
+        <p:grpSpPr>
+          <a:xfrm rot="0">
+            <a:off x="5962650" y="5248275"/>
+            <a:ext cx="266700" cy="266700"/>
+            <a:chOff x="0" y="0"/>
+            <a:chExt cx="105363" cy="105363"/>
+          </a:xfrm>
+        </p:grpSpPr>
+        <p:sp>
+          <p:nvSpPr>
+            <p:cNvPr name="Freeform 7" id="7"/>
+            <p:cNvSpPr/>
+            <p:nvPr/>
+          </p:nvSpPr>
+          <p:spPr>
+            <a:xfrm flipH="false" flipV="false" rot="0">
+              <a:off x="0" y="0"/>
+              <a:ext cx="105363" cy="105363"/>
+            </a:xfrm>
+            <a:custGeom>
+              <a:avLst/>
+              <a:gdLst/>
+              <a:ahLst/>
+              <a:cxnLst/>
+              <a:rect r="r" b="b" t="t" l="l"/>
+              <a:pathLst>
+                <a:path h="105363" w="105363">
+                  <a:moveTo>
+                    <a:pt x="52681" y="0"/>
+                  </a:moveTo>
+                  <a:cubicBezTo>
+                    <a:pt x="23586" y="0"/>
+                    <a:pt x="0" y="23586"/>
+                    <a:pt x="0" y="52681"/>
+                  </a:cubicBezTo>
+                  <a:cubicBezTo>
+                    <a:pt x="0" y="81777"/>
+                    <a:pt x="23586" y="105363"/>
+                    <a:pt x="52681" y="105363"/>
+                  </a:cubicBezTo>
+                  <a:cubicBezTo>
+                    <a:pt x="81777" y="105363"/>
+                    <a:pt x="105363" y="81777"/>
+                    <a:pt x="105363" y="52681"/>
+                  </a:cubicBezTo>
+                  <a:cubicBezTo>
+                    <a:pt x="105363" y="23586"/>
+                    <a:pt x="81777" y="0"/>
+                    <a:pt x="52681" y="0"/>
+                  </a:cubicBezTo>
+                  <a:close/>
+                </a:path>
+              </a:pathLst>
+            </a:custGeom>
+            <a:solidFill>
+              <a:srgbClr val="C96331"/>
+            </a:solidFill>
+          </p:spPr>
+        </p:sp>
+        <p:sp>
+          <p:nvSpPr>
+            <p:cNvPr name="TextBox 8" id="8"/>
+            <p:cNvSpPr txBox="true"/>
+            <p:nvPr/>
+          </p:nvSpPr>
+          <p:spPr>
+            <a:xfrm>
+              <a:off x="9878" y="9878"/>
+              <a:ext cx="85607" cy="85607"/>
+            </a:xfrm>
+            <a:prstGeom prst="rect">
+              <a:avLst/>
+            </a:prstGeom>
+          </p:spPr>
+          <p:txBody>
+            <a:bodyPr anchor="ctr" rtlCol="false" tIns="50800" lIns="50800" bIns="50800" rIns="50800"/>
+            <a:lstStyle/>
+            <a:p>
+              <a:pPr algn="ctr">
+                <a:lnSpc>
+                  <a:spcPts val="1372"/>
+                </a:lnSpc>
+              </a:pPr>
+            </a:p>
+          </p:txBody>
+        </p:sp>
+      </p:grpSp>
+      <p:sp>
+        <p:nvSpPr>
+          <p:cNvPr name="TextBox 9" id="9"/>
           <p:cNvSpPr txBox="true"/>
           <p:nvPr/>
         </p:nvSpPr>
@@ -6754,7 +6886,7 @@
       </p:sp>
       <p:sp>
         <p:nvSpPr>
-          <p:cNvPr name="TextBox 6" id="6"/>
+          <p:cNvPr name="TextBox 10" id="10"/>
           <p:cNvSpPr txBox="true"/>
           <p:nvPr/>
         </p:nvSpPr>
@@ -6795,14 +6927,14 @@
       </p:sp>
       <p:sp>
         <p:nvSpPr>
-          <p:cNvPr name="TextBox 7" id="7"/>
+          <p:cNvPr name="TextBox 11" id="11"/>
           <p:cNvSpPr txBox="true"/>
           <p:nvPr/>
         </p:nvSpPr>
         <p:spPr>
           <a:xfrm rot="0">
-            <a:off x="609600" y="1924050"/>
-            <a:ext cx="10972800" cy="824484"/>
+            <a:off x="609600" y="1057275"/>
+            <a:ext cx="10972800" cy="674624"/>
           </a:xfrm>
           <a:prstGeom prst="rect">
             <a:avLst/>
@@ -6816,11 +6948,11 @@
           <a:p>
             <a:pPr algn="l">
               <a:lnSpc>
-                <a:spcPts val="6588"/>
+                <a:spcPts val="5368"/>
               </a:lnSpc>
             </a:pPr>
             <a:r>
-              <a:rPr lang="en-US" b="true" sz="5400">
+              <a:rPr lang="en-US" b="true" sz="4400">
                 <a:solidFill>
                   <a:srgbClr val="151521"/>
                 </a:solidFill>
@@ -6829,21 +6961,21 @@
                 <a:cs typeface="DM Sans Bold"/>
                 <a:sym typeface="DM Sans Bold"/>
               </a:rPr>
-              <a:t>Stuck on one step.</a:t>
-            </a:r>
-          </a:p>
-        </p:txBody>
-      </p:sp>
-      <p:sp>
-        <p:nvSpPr>
-          <p:cNvPr name="TextBox 8" id="8"/>
+              <a:t>Find the missing skill.</a:t>
+            </a:r>
+          </a:p>
+        </p:txBody>
+      </p:sp>
+      <p:sp>
+        <p:nvSpPr>
+          <p:cNvPr name="TextBox 12" id="12"/>
           <p:cNvSpPr txBox="true"/>
           <p:nvPr/>
         </p:nvSpPr>
         <p:spPr>
           <a:xfrm rot="0">
-            <a:off x="609600" y="2867025"/>
-            <a:ext cx="10972800" cy="824484"/>
+            <a:off x="609600" y="1743075"/>
+            <a:ext cx="10972800" cy="674624"/>
           </a:xfrm>
           <a:prstGeom prst="rect">
             <a:avLst/>
@@ -6857,11 +6989,11 @@
           <a:p>
             <a:pPr algn="l">
               <a:lnSpc>
-                <a:spcPts val="6588"/>
+                <a:spcPts val="5368"/>
               </a:lnSpc>
             </a:pPr>
             <a:r>
-              <a:rPr lang="en-US" b="true" sz="5400">
+              <a:rPr lang="en-US" b="true" sz="4400">
                 <a:solidFill>
                   <a:srgbClr val="5753FA"/>
                 </a:solidFill>
@@ -6870,21 +7002,21 @@
                 <a:cs typeface="DM Sans Bold"/>
                 <a:sym typeface="DM Sans Bold"/>
               </a:rPr>
-              <a:t>Lost in whole lessons.</a:t>
-            </a:r>
-          </a:p>
-        </p:txBody>
-      </p:sp>
-      <p:sp>
-        <p:nvSpPr>
-          <p:cNvPr name="TextBox 9" id="9"/>
+              <a:t>Get back to today’s lesson.</a:t>
+            </a:r>
+          </a:p>
+        </p:txBody>
+      </p:sp>
+      <p:sp>
+        <p:nvSpPr>
+          <p:cNvPr name="TextBox 13" id="13"/>
           <p:cNvSpPr txBox="true"/>
           <p:nvPr/>
         </p:nvSpPr>
         <p:spPr>
           <a:xfrm rot="0">
-            <a:off x="609600" y="4391025"/>
-            <a:ext cx="10972800" cy="393573"/>
+            <a:off x="609600" y="2733675"/>
+            <a:ext cx="10972800" cy="651891"/>
           </a:xfrm>
           <a:prstGeom prst="rect">
             <a:avLst/>
@@ -6898,11 +7030,11 @@
           <a:p>
             <a:pPr algn="l">
               <a:lnSpc>
-                <a:spcPts val="3111"/>
+                <a:spcPts val="2562"/>
               </a:lnSpc>
             </a:pPr>
             <a:r>
-              <a:rPr lang="en-US" sz="2550">
+              <a:rPr lang="en-US" sz="2100">
                 <a:solidFill>
                   <a:srgbClr val="536073"/>
                 </a:solidFill>
@@ -6911,21 +7043,40 @@
                 <a:cs typeface="DM Sans"/>
                 <a:sym typeface="DM Sans"/>
               </a:rPr>
-              <a:t>Find the step. Get a focused Khan repair. Return to your task.</a:t>
-            </a:r>
-          </a:p>
-        </p:txBody>
-      </p:sp>
-      <p:sp>
-        <p:nvSpPr>
-          <p:cNvPr name="TextBox 10" id="10"/>
+              <a:t>THE PROBLEM</a:t>
+            </a:r>
+          </a:p>
+          <a:p>
+            <a:pPr algn="l">
+              <a:lnSpc>
+                <a:spcPts val="2562"/>
+              </a:lnSpc>
+            </a:pPr>
+            <a:r>
+              <a:rPr lang="en-US" sz="2100">
+                <a:solidFill>
+                  <a:srgbClr val="536073"/>
+                </a:solidFill>
+                <a:latin typeface="DM Sans"/>
+                <a:ea typeface="DM Sans"/>
+                <a:cs typeface="DM Sans"/>
+                <a:sym typeface="DM Sans"/>
+              </a:rPr>
+              <a:t>A student gets stuck, but doesn’t know which earlier skill to review.</a:t>
+            </a:r>
+          </a:p>
+        </p:txBody>
+      </p:sp>
+      <p:sp>
+        <p:nvSpPr>
+          <p:cNvPr name="TextBox 14" id="14"/>
           <p:cNvSpPr txBox="true"/>
           <p:nvPr/>
         </p:nvSpPr>
         <p:spPr>
           <a:xfrm rot="0">
-            <a:off x="609600" y="6105525"/>
-            <a:ext cx="9525000" cy="262318"/>
+            <a:off x="609600" y="6448425"/>
+            <a:ext cx="9525000" cy="215519"/>
           </a:xfrm>
           <a:prstGeom prst="rect">
             <a:avLst/>
@@ -6939,11 +7090,11 @@
           <a:p>
             <a:pPr algn="l">
               <a:lnSpc>
-                <a:spcPts val="2104"/>
+                <a:spcPts val="1708"/>
               </a:lnSpc>
             </a:pPr>
             <a:r>
-              <a:rPr lang="en-US" sz="1725">
+              <a:rPr lang="en-US" sz="1400">
                 <a:solidFill>
                   <a:srgbClr val="536073"/>
                 </a:solidFill>
@@ -6953,6 +7104,186 @@
                 <a:sym typeface="DM Sans"/>
               </a:rPr>
               <a:t>University of the Philippines Manila</a:t>
+            </a:r>
+          </a:p>
+        </p:txBody>
+      </p:sp>
+      <p:sp>
+        <p:nvSpPr>
+          <p:cNvPr name="TextBox 15" id="15"/>
+          <p:cNvSpPr txBox="true"/>
+          <p:nvPr/>
+        </p:nvSpPr>
+        <p:spPr>
+          <a:xfrm rot="0">
+            <a:off x="285750" y="3695700"/>
+            <a:ext cx="2857500" cy="614045"/>
+          </a:xfrm>
+          <a:prstGeom prst="rect">
+            <a:avLst/>
+          </a:prstGeom>
+        </p:spPr>
+        <p:txBody>
+          <a:bodyPr anchor="t" rtlCol="false" tIns="0" lIns="0" bIns="0" rIns="0">
+            <a:spAutoFit/>
+          </a:bodyPr>
+          <a:lstStyle/>
+          <a:p>
+            <a:pPr algn="ctr">
+              <a:lnSpc>
+                <a:spcPts val="2440"/>
+              </a:lnSpc>
+            </a:pPr>
+            <a:r>
+              <a:rPr lang="en-US" sz="2000" b="true">
+                <a:solidFill>
+                  <a:srgbClr val="536073"/>
+                </a:solidFill>
+                <a:latin typeface="DM Sans Bold"/>
+                <a:ea typeface="DM Sans Bold"/>
+                <a:cs typeface="DM Sans Bold"/>
+                <a:sym typeface="DM Sans Bold"/>
+              </a:rPr>
+              <a:t>Check today’s</a:t>
+            </a:r>
+          </a:p>
+          <a:p>
+            <a:pPr algn="ctr">
+              <a:lnSpc>
+                <a:spcPts val="2440"/>
+              </a:lnSpc>
+            </a:pPr>
+            <a:r>
+              <a:rPr lang="en-US" b="true" sz="2000">
+                <a:solidFill>
+                  <a:srgbClr val="536073"/>
+                </a:solidFill>
+                <a:latin typeface="DM Sans Bold"/>
+                <a:ea typeface="DM Sans Bold"/>
+                <a:cs typeface="DM Sans Bold"/>
+                <a:sym typeface="DM Sans Bold"/>
+              </a:rPr>
+              <a:t>task</a:t>
+            </a:r>
+          </a:p>
+        </p:txBody>
+      </p:sp>
+      <p:sp>
+        <p:nvSpPr>
+          <p:cNvPr name="TextBox 16" id="16"/>
+          <p:cNvSpPr txBox="true"/>
+          <p:nvPr/>
+        </p:nvSpPr>
+        <p:spPr>
+          <a:xfrm rot="0">
+            <a:off x="4000500" y="5562600"/>
+            <a:ext cx="4191000" cy="614045"/>
+          </a:xfrm>
+          <a:prstGeom prst="rect">
+            <a:avLst/>
+          </a:prstGeom>
+        </p:spPr>
+        <p:txBody>
+          <a:bodyPr anchor="t" rtlCol="false" tIns="0" lIns="0" bIns="0" rIns="0">
+            <a:spAutoFit/>
+          </a:bodyPr>
+          <a:lstStyle/>
+          <a:p>
+            <a:pPr algn="ctr">
+              <a:lnSpc>
+                <a:spcPts val="2440"/>
+              </a:lnSpc>
+            </a:pPr>
+            <a:r>
+              <a:rPr lang="en-US" sz="2000" b="true">
+                <a:solidFill>
+                  <a:srgbClr val="536073"/>
+                </a:solidFill>
+                <a:latin typeface="DM Sans Bold"/>
+                <a:ea typeface="DM Sans Bold"/>
+                <a:cs typeface="DM Sans Bold"/>
+                <a:sym typeface="DM Sans Bold"/>
+              </a:rPr>
+              <a:t>Practice the missing skill</a:t>
+            </a:r>
+          </a:p>
+          <a:p>
+            <a:pPr algn="ctr">
+              <a:lnSpc>
+                <a:spcPts val="2440"/>
+              </a:lnSpc>
+            </a:pPr>
+            <a:r>
+              <a:rPr lang="en-US" b="true" sz="2000">
+                <a:solidFill>
+                  <a:srgbClr val="536073"/>
+                </a:solidFill>
+                <a:latin typeface="DM Sans Bold"/>
+                <a:ea typeface="DM Sans Bold"/>
+                <a:cs typeface="DM Sans Bold"/>
+                <a:sym typeface="DM Sans Bold"/>
+              </a:rPr>
+              <a:t>with Khan Academy</a:t>
+            </a:r>
+          </a:p>
+        </p:txBody>
+      </p:sp>
+      <p:sp>
+        <p:nvSpPr>
+          <p:cNvPr name="TextBox 17" id="17"/>
+          <p:cNvSpPr txBox="true"/>
+          <p:nvPr/>
+        </p:nvSpPr>
+        <p:spPr>
+          <a:xfrm rot="0">
+            <a:off x="8858250" y="3695700"/>
+            <a:ext cx="3238500" cy="614045"/>
+          </a:xfrm>
+          <a:prstGeom prst="rect">
+            <a:avLst/>
+          </a:prstGeom>
+        </p:spPr>
+        <p:txBody>
+          <a:bodyPr anchor="t" rtlCol="false" tIns="0" lIns="0" bIns="0" rIns="0">
+            <a:spAutoFit/>
+          </a:bodyPr>
+          <a:lstStyle/>
+          <a:p>
+            <a:pPr algn="ctr">
+              <a:lnSpc>
+                <a:spcPts val="2440"/>
+              </a:lnSpc>
+            </a:pPr>
+            <a:r>
+              <a:rPr lang="en-US" b="true" sz="2000">
+                <a:solidFill>
+                  <a:srgbClr val="087E70"/>
+                </a:solidFill>
+                <a:latin typeface="DM Sans Bold"/>
+                <a:ea typeface="DM Sans Bold"/>
+                <a:cs typeface="DM Sans Bold"/>
+                <a:sym typeface="DM Sans Bold"/>
+              </a:rPr>
+              <a:t>Return to today’s lesson</a:t>
+            </a:r>
+          </a:p>
+          <a:p>
+            <a:pPr algn="ctr">
+              <a:lnSpc>
+                <a:spcPts val="2440"/>
+              </a:lnSpc>
+            </a:pPr>
+            <a:r>
+              <a:rPr lang="en-US" b="true" sz="2000">
+                <a:solidFill>
+                  <a:srgbClr val="087E70"/>
+                </a:solidFill>
+                <a:latin typeface="DM Sans Bold"/>
+                <a:ea typeface="DM Sans Bold"/>
+                <a:cs typeface="DM Sans Bold"/>
+                <a:sym typeface="DM Sans Bold"/>
+              </a:rPr>
+              <a:t>with a fresh check</a:t>
             </a:r>
           </a:p>
         </p:txBody>
@@ -8013,7 +8344,7 @@
                 <a:cs typeface="DM Sans Bold"/>
                 <a:sym typeface="DM Sans Bold"/>
               </a:rPr>
-              <a:t>The route is the reward</a:t>
+              <a:t>Skip the review you don’t need.</a:t>
             </a:r>
           </a:p>
         </p:txBody>
@@ -13084,7 +13415,7 @@
         </p:nvSpPr>
         <p:spPr>
           <a:xfrm rot="0">
-            <a:off x="609600" y="1943100"/>
+            <a:off x="609600" y="1276350"/>
             <a:ext cx="10972800" cy="1898904"/>
           </a:xfrm>
           <a:prstGeom prst="rect">
@@ -13239,6 +13570,45 @@
             </a:r>
           </a:p>
         </p:txBody>
+      </p:sp>
+      <p:sp>
+        <p:nvSpPr>
+          <p:cNvPr name="Freeform 11" id="11"/>
+          <p:cNvSpPr/>
+          <p:nvPr/>
+        </p:nvSpPr>
+        <p:spPr>
+          <a:xfrm>
+            <a:off x="1714500" y="3714750"/>
+            <a:ext cx="8763000" cy="914864"/>
+          </a:xfrm>
+          <a:custGeom>
+            <a:avLst/>
+            <a:gdLst/>
+            <a:ahLst/>
+            <a:cxnLst/>
+            <a:rect r="r" b="b" t="t" l="l"/>
+            <a:pathLst>
+              <a:path h="914864" w="8763000">
+                <a:moveTo>
+                  <a:pt x="0" y="0"/>
+                </a:moveTo>
+                <a:quadBezTo>
+                  <a:pt x="4381500" y="1829728"/>
+                  <a:pt x="8763000" y="0"/>
+                </a:quadBezTo>
+              </a:path>
+            </a:pathLst>
+          </a:custGeom>
+          <a:ln cap="rnd" w="66675">
+            <a:solidFill>
+              <a:srgbClr val="C96331"/>
+            </a:solidFill>
+            <a:prstDash val="solid"/>
+            <a:headEnd type="oval" len="lg" w="lg"/>
+            <a:tailEnd type="arrow" len="sm" w="med"/>
+          </a:ln>
+        </p:spPr>
       </p:sp>
     </p:spTree>
   </p:cSld>
@@ -14667,7 +15037,7 @@
                 <a:cs typeface="DM Sans Bold"/>
                 <a:sym typeface="DM Sans Bold"/>
               </a:rPr>
-              <a:t>A short repair. A clear way back.</a:t>
+              <a:t>How BACKTRACK gets a learner unstuck</a:t>
             </a:r>
           </a:p>
         </p:txBody>
@@ -15117,6 +15487,25 @@
               </a:lnSpc>
             </a:pPr>
             <a:r>
+              <a:rPr lang="en-US" sz="2175" b="true">
+                <a:solidFill>
+                  <a:srgbClr val="151521"/>
+                </a:solidFill>
+                <a:latin typeface="DM Sans Bold"/>
+                <a:ea typeface="DM Sans Bold"/>
+                <a:cs typeface="DM Sans Bold"/>
+                <a:sym typeface="DM Sans Bold"/>
+              </a:rPr>
+              <a:t>Check earlier</a:t>
+            </a:r>
+          </a:p>
+          <a:p>
+            <a:pPr algn="ctr">
+              <a:lnSpc>
+                <a:spcPts val="2653"/>
+              </a:lnSpc>
+            </a:pPr>
+            <a:r>
               <a:rPr lang="en-US" b="true" sz="2175">
                 <a:solidFill>
                   <a:srgbClr val="151521"/>
@@ -15126,7 +15515,7 @@
                 <a:cs typeface="DM Sans Bold"/>
                 <a:sym typeface="DM Sans Bold"/>
               </a:rPr>
-              <a:t>Find a useful earlier step</a:t>
+              <a:t>skills</a:t>
             </a:r>
           </a:p>
         </p:txBody>
@@ -15410,7 +15799,7 @@
         <p:spPr>
           <a:xfrm rot="0">
             <a:off x="6400800" y="3629025"/>
-            <a:ext cx="2286000" cy="670751"/>
+            <a:ext cx="2286000" cy="1004125"/>
           </a:xfrm>
           <a:prstGeom prst="rect">
             <a:avLst/>
@@ -15421,6 +15810,25 @@
             <a:spAutoFit/>
           </a:bodyPr>
           <a:lstStyle/>
+          <a:p>
+            <a:pPr algn="ctr">
+              <a:lnSpc>
+                <a:spcPts val="2653"/>
+              </a:lnSpc>
+            </a:pPr>
+            <a:r>
+              <a:rPr lang="en-US" sz="2175" b="true">
+                <a:solidFill>
+                  <a:srgbClr val="151521"/>
+                </a:solidFill>
+                <a:latin typeface="DM Sans Bold"/>
+                <a:ea typeface="DM Sans Bold"/>
+                <a:cs typeface="DM Sans Bold"/>
+                <a:sym typeface="DM Sans Bold"/>
+              </a:rPr>
+              <a:t>Practice the step</a:t>
+            </a:r>
+          </a:p>
           <a:p>
             <a:pPr algn="ctr">
               <a:lnSpc>
@@ -15437,7 +15845,7 @@
                 <a:cs typeface="DM Sans Bold"/>
                 <a:sym typeface="DM Sans Bold"/>
               </a:rPr>
-              <a:t>Learn + practise with Khan</a:t>
+              <a:t>with Khan</a:t>
             </a:r>
           </a:p>
         </p:txBody>
@@ -15739,6 +16147,25 @@
               </a:lnSpc>
             </a:pPr>
             <a:r>
+              <a:rPr lang="en-US" sz="2175" b="true">
+                <a:solidFill>
+                  <a:srgbClr val="151521"/>
+                </a:solidFill>
+                <a:latin typeface="DM Sans Bold"/>
+                <a:ea typeface="DM Sans Bold"/>
+                <a:cs typeface="DM Sans Bold"/>
+                <a:sym typeface="DM Sans Bold"/>
+              </a:rPr>
+              <a:t>Try it again with</a:t>
+            </a:r>
+          </a:p>
+          <a:p>
+            <a:pPr algn="ctr">
+              <a:lnSpc>
+                <a:spcPts val="2653"/>
+              </a:lnSpc>
+            </a:pPr>
+            <a:r>
               <a:rPr lang="en-US" b="true" sz="2175">
                 <a:solidFill>
                   <a:srgbClr val="151521"/>
@@ -15748,7 +16175,7 @@
                 <a:cs typeface="DM Sans Bold"/>
                 <a:sym typeface="DM Sans Bold"/>
               </a:rPr>
-              <a:t>Try a fresh current task</a:t>
+              <a:t>fresh numbers</a:t>
             </a:r>
           </a:p>
         </p:txBody>
@@ -15789,7 +16216,7 @@
                 <a:cs typeface="DM Sans"/>
                 <a:sym typeface="DM Sans"/>
               </a:rPr>
-              <a:t>Your answer shapes the route. The repair fits the missing step.</a:t>
+              <a:t>Answers choose the next step. Fresh problems check the return.</a:t>
             </a:r>
           </a:p>
         </p:txBody>

</xml_diff>

<commit_message>
Refine GPS diagrams and synchronize the competition package
</commit_message>
<xml_diff>
--- a/output/BACKTRACK_KEIC_2026.pptx
+++ b/output/BACKTRACK_KEIC_2026.pptx
@@ -6718,9 +6718,9 @@
           <p:nvPr/>
         </p:nvSpPr>
         <p:spPr>
-          <a:xfrm>
-            <a:off x="1714500" y="4476750"/>
-            <a:ext cx="8763000" cy="914864"/>
+          <a:xfrm flipH="false" flipV="false" rot="0">
+            <a:off x="1524000" y="4095750"/>
+            <a:ext cx="9715500" cy="1428750"/>
           </a:xfrm>
           <a:custGeom>
             <a:avLst/>
@@ -6729,25 +6729,38 @@
             <a:cxnLst/>
             <a:rect r="r" b="b" t="t" l="l"/>
             <a:pathLst>
-              <a:path h="914864" w="8763000">
+              <a:path h="1428750" w="9715500">
                 <a:moveTo>
                   <a:pt x="0" y="0"/>
                 </a:moveTo>
-                <a:quadBezTo>
-                  <a:pt x="4381500" y="1829728"/>
-                  <a:pt x="8763000" y="0"/>
-                </a:quadBezTo>
+                <a:lnTo>
+                  <a:pt x="9715500" y="0"/>
+                </a:lnTo>
+                <a:lnTo>
+                  <a:pt x="9715500" y="1428750"/>
+                </a:lnTo>
+                <a:lnTo>
+                  <a:pt x="0" y="1428750"/>
+                </a:lnTo>
+                <a:lnTo>
+                  <a:pt x="0" y="0"/>
+                </a:lnTo>
+                <a:close/>
               </a:path>
             </a:pathLst>
           </a:custGeom>
-          <a:ln cap="rnd" w="66675">
-            <a:solidFill>
-              <a:srgbClr val="C96331"/>
-            </a:solidFill>
-            <a:prstDash val="solid"/>
-            <a:headEnd type="oval" len="lg" w="lg"/>
-            <a:tailEnd type="arrow" len="sm" w="med"/>
-          </a:ln>
+          <a:blipFill>
+            <a:blip r:embed="rId4">
+              <a:extLst>
+                <a:ext uri="{96DAC541-7B7A-43D3-8B79-37D633B846F1}">
+                  <asvg:svgBlip xmlns:asvg="http://schemas.microsoft.com/office/drawing/2016/SVG/main" r:embed="rId5"/>
+                </a:ext>
+              </a:extLst>
+            </a:blip>
+            <a:stretch>
+              <a:fillRect l="0" t="0" r="0" b="0"/>
+            </a:stretch>
+          </a:blipFill>
         </p:spPr>
       </p:sp>
       <p:grpSp>
@@ -6758,7 +6771,7 @@
         </p:nvGrpSpPr>
         <p:grpSpPr>
           <a:xfrm rot="0">
-            <a:off x="5962650" y="5248275"/>
+            <a:off x="5581650" y="5295900"/>
             <a:ext cx="266700" cy="266700"/>
             <a:chOff x="0" y="0"/>
             <a:chExt cx="105363" cy="105363"/>
@@ -7116,7 +7129,7 @@
         </p:nvSpPr>
         <p:spPr>
           <a:xfrm rot="0">
-            <a:off x="285750" y="3695700"/>
+            <a:off x="285750" y="3790950"/>
             <a:ext cx="2857500" cy="614045"/>
           </a:xfrm>
           <a:prstGeom prst="rect">
@@ -7176,7 +7189,7 @@
         </p:nvSpPr>
         <p:spPr>
           <a:xfrm rot="0">
-            <a:off x="4000500" y="5562600"/>
+            <a:off x="3619500" y="5610225"/>
             <a:ext cx="4191000" cy="614045"/>
           </a:xfrm>
           <a:prstGeom prst="rect">
@@ -7236,7 +7249,7 @@
         </p:nvSpPr>
         <p:spPr>
           <a:xfrm rot="0">
-            <a:off x="8858250" y="3695700"/>
+            <a:off x="8286750" y="3467100"/>
             <a:ext cx="3238500" cy="614045"/>
           </a:xfrm>
           <a:prstGeom prst="rect">
@@ -7288,6 +7301,192 @@
           </a:p>
         </p:txBody>
       </p:sp>
+      <p:grpSp>
+        <p:nvGrpSpPr>
+          <p:cNvPr name="Group 18" id="18"/>
+          <p:cNvGrpSpPr/>
+          <p:nvPr/>
+        </p:nvGrpSpPr>
+        <p:grpSpPr>
+          <a:xfrm rot="0">
+            <a:off x="1581150" y="4438650"/>
+            <a:ext cx="266700" cy="266700"/>
+            <a:chOff x="0" y="0"/>
+            <a:chExt cx="105363" cy="105363"/>
+          </a:xfrm>
+        </p:grpSpPr>
+        <p:sp>
+          <p:nvSpPr>
+            <p:cNvPr name="Freeform 19" id="19"/>
+            <p:cNvSpPr/>
+            <p:nvPr/>
+          </p:nvSpPr>
+          <p:spPr>
+            <a:xfrm flipH="false" flipV="false" rot="0">
+              <a:off x="0" y="0"/>
+              <a:ext cx="105363" cy="105363"/>
+            </a:xfrm>
+            <a:custGeom>
+              <a:avLst/>
+              <a:gdLst/>
+              <a:ahLst/>
+              <a:cxnLst/>
+              <a:rect r="r" b="b" t="t" l="l"/>
+              <a:pathLst>
+                <a:path h="105363" w="105363">
+                  <a:moveTo>
+                    <a:pt x="52681" y="0"/>
+                  </a:moveTo>
+                  <a:cubicBezTo>
+                    <a:pt x="23586" y="0"/>
+                    <a:pt x="0" y="23586"/>
+                    <a:pt x="0" y="52681"/>
+                  </a:cubicBezTo>
+                  <a:cubicBezTo>
+                    <a:pt x="0" y="81777"/>
+                    <a:pt x="23586" y="105363"/>
+                    <a:pt x="52681" y="105363"/>
+                  </a:cubicBezTo>
+                  <a:cubicBezTo>
+                    <a:pt x="81777" y="105363"/>
+                    <a:pt x="105363" y="81777"/>
+                    <a:pt x="105363" y="52681"/>
+                  </a:cubicBezTo>
+                  <a:cubicBezTo>
+                    <a:pt x="105363" y="23586"/>
+                    <a:pt x="81777" y="0"/>
+                    <a:pt x="52681" y="0"/>
+                  </a:cubicBezTo>
+                  <a:close/>
+                </a:path>
+              </a:pathLst>
+            </a:custGeom>
+            <a:solidFill>
+              <a:srgbClr val="C96331"/>
+            </a:solidFill>
+          </p:spPr>
+        </p:sp>
+        <p:sp>
+          <p:nvSpPr>
+            <p:cNvPr name="TextBox 20" id="20"/>
+            <p:cNvSpPr txBox="true"/>
+            <p:nvPr/>
+          </p:nvSpPr>
+          <p:spPr>
+            <a:xfrm>
+              <a:off x="9878" y="9878"/>
+              <a:ext cx="85607" cy="85607"/>
+            </a:xfrm>
+            <a:prstGeom prst="rect">
+              <a:avLst/>
+            </a:prstGeom>
+          </p:spPr>
+          <p:txBody>
+            <a:bodyPr anchor="ctr" rtlCol="false" tIns="50800" lIns="50800" bIns="50800" rIns="50800"/>
+            <a:lstStyle/>
+            <a:p>
+              <a:pPr algn="ctr">
+                <a:lnSpc>
+                  <a:spcPts val="1372"/>
+                </a:lnSpc>
+              </a:pPr>
+            </a:p>
+          </p:txBody>
+        </p:sp>
+      </p:grpSp>
+      <p:grpSp>
+        <p:nvGrpSpPr>
+          <p:cNvPr name="Group 21" id="21"/>
+          <p:cNvGrpSpPr/>
+          <p:nvPr/>
+        </p:nvGrpSpPr>
+        <p:grpSpPr>
+          <a:xfrm rot="0">
+            <a:off x="9772650" y="4152900"/>
+            <a:ext cx="266700" cy="266700"/>
+            <a:chOff x="0" y="0"/>
+            <a:chExt cx="105363" cy="105363"/>
+          </a:xfrm>
+        </p:grpSpPr>
+        <p:sp>
+          <p:nvSpPr>
+            <p:cNvPr name="Freeform 22" id="22"/>
+            <p:cNvSpPr/>
+            <p:nvPr/>
+          </p:nvSpPr>
+          <p:spPr>
+            <a:xfrm flipH="false" flipV="false" rot="0">
+              <a:off x="0" y="0"/>
+              <a:ext cx="105363" cy="105363"/>
+            </a:xfrm>
+            <a:custGeom>
+              <a:avLst/>
+              <a:gdLst/>
+              <a:ahLst/>
+              <a:cxnLst/>
+              <a:rect r="r" b="b" t="t" l="l"/>
+              <a:pathLst>
+                <a:path h="105363" w="105363">
+                  <a:moveTo>
+                    <a:pt x="52681" y="0"/>
+                  </a:moveTo>
+                  <a:cubicBezTo>
+                    <a:pt x="23586" y="0"/>
+                    <a:pt x="0" y="23586"/>
+                    <a:pt x="0" y="52681"/>
+                  </a:cubicBezTo>
+                  <a:cubicBezTo>
+                    <a:pt x="0" y="81777"/>
+                    <a:pt x="23586" y="105363"/>
+                    <a:pt x="52681" y="105363"/>
+                  </a:cubicBezTo>
+                  <a:cubicBezTo>
+                    <a:pt x="81777" y="105363"/>
+                    <a:pt x="105363" y="81777"/>
+                    <a:pt x="105363" y="52681"/>
+                  </a:cubicBezTo>
+                  <a:cubicBezTo>
+                    <a:pt x="105363" y="23586"/>
+                    <a:pt x="81777" y="0"/>
+                    <a:pt x="52681" y="0"/>
+                  </a:cubicBezTo>
+                  <a:close/>
+                </a:path>
+              </a:pathLst>
+            </a:custGeom>
+            <a:solidFill>
+              <a:srgbClr val="087E70"/>
+            </a:solidFill>
+          </p:spPr>
+        </p:sp>
+        <p:sp>
+          <p:nvSpPr>
+            <p:cNvPr name="TextBox 23" id="23"/>
+            <p:cNvSpPr txBox="true"/>
+            <p:nvPr/>
+          </p:nvSpPr>
+          <p:spPr>
+            <a:xfrm>
+              <a:off x="9878" y="9878"/>
+              <a:ext cx="85607" cy="85607"/>
+            </a:xfrm>
+            <a:prstGeom prst="rect">
+              <a:avLst/>
+            </a:prstGeom>
+          </p:spPr>
+          <p:txBody>
+            <a:bodyPr anchor="ctr" rtlCol="false" tIns="50800" lIns="50800" bIns="50800" rIns="50800"/>
+            <a:lstStyle/>
+            <a:p>
+              <a:pPr algn="ctr">
+                <a:lnSpc>
+                  <a:spcPts val="1372"/>
+                </a:lnSpc>
+              </a:pPr>
+            </a:p>
+          </p:txBody>
+        </p:sp>
+      </p:grpSp>
     </p:spTree>
   </p:cSld>
   <p:clrMapOvr>
@@ -13327,7 +13526,59 @@
       </p:grpSp>
       <p:sp>
         <p:nvSpPr>
-          <p:cNvPr name="TextBox 5" id="5"/>
+          <p:cNvPr name="Freeform 5" id="5"/>
+          <p:cNvSpPr/>
+          <p:nvPr/>
+        </p:nvSpPr>
+        <p:spPr>
+          <a:xfrm flipH="false" flipV="false" rot="0">
+            <a:off x="1619250" y="3238500"/>
+            <a:ext cx="9525000" cy="1400735"/>
+          </a:xfrm>
+          <a:custGeom>
+            <a:avLst/>
+            <a:gdLst/>
+            <a:ahLst/>
+            <a:cxnLst/>
+            <a:rect r="r" b="b" t="t" l="l"/>
+            <a:pathLst>
+              <a:path h="1400735" w="9525000">
+                <a:moveTo>
+                  <a:pt x="0" y="0"/>
+                </a:moveTo>
+                <a:lnTo>
+                  <a:pt x="9525000" y="0"/>
+                </a:lnTo>
+                <a:lnTo>
+                  <a:pt x="9525000" y="1400735"/>
+                </a:lnTo>
+                <a:lnTo>
+                  <a:pt x="0" y="1400735"/>
+                </a:lnTo>
+                <a:lnTo>
+                  <a:pt x="0" y="0"/>
+                </a:lnTo>
+                <a:close/>
+              </a:path>
+            </a:pathLst>
+          </a:custGeom>
+          <a:blipFill>
+            <a:blip r:embed="rId4">
+              <a:extLst>
+                <a:ext uri="{96DAC541-7B7A-43D3-8B79-37D633B846F1}">
+                  <asvg:svgBlip xmlns:asvg="http://schemas.microsoft.com/office/drawing/2016/SVG/main" r:embed="rId5"/>
+                </a:ext>
+              </a:extLst>
+            </a:blip>
+            <a:stretch>
+              <a:fillRect l="0" t="0" r="0" b="0"/>
+            </a:stretch>
+          </a:blipFill>
+        </p:spPr>
+      </p:sp>
+      <p:sp>
+        <p:nvSpPr>
+          <p:cNvPr name="TextBox 6" id="6"/>
           <p:cNvSpPr txBox="true"/>
           <p:nvPr/>
         </p:nvSpPr>
@@ -13368,7 +13619,7 @@
       </p:sp>
       <p:sp>
         <p:nvSpPr>
-          <p:cNvPr name="TextBox 6" id="6"/>
+          <p:cNvPr name="TextBox 7" id="7"/>
           <p:cNvSpPr txBox="true"/>
           <p:nvPr/>
         </p:nvSpPr>
@@ -13409,7 +13660,7 @@
       </p:sp>
       <p:sp>
         <p:nvSpPr>
-          <p:cNvPr name="TextBox 7" id="7"/>
+          <p:cNvPr name="TextBox 8" id="8"/>
           <p:cNvSpPr txBox="true"/>
           <p:nvPr/>
         </p:nvSpPr>
@@ -13427,6 +13678,25 @@
             <a:spAutoFit/>
           </a:bodyPr>
           <a:lstStyle/>
+          <a:p>
+            <a:pPr algn="l">
+              <a:lnSpc>
+                <a:spcPts val="7503"/>
+              </a:lnSpc>
+            </a:pPr>
+            <a:r>
+              <a:rPr lang="en-US" sz="6150" b="true">
+                <a:solidFill>
+                  <a:srgbClr val="5753FA"/>
+                </a:solidFill>
+                <a:latin typeface="DM Sans Bold"/>
+                <a:ea typeface="DM Sans Bold"/>
+                <a:cs typeface="DM Sans Bold"/>
+                <a:sym typeface="DM Sans Bold"/>
+              </a:rPr>
+              <a:t>A route back to</a:t>
+            </a:r>
+          </a:p>
           <a:p>
             <a:pPr algn="l">
               <a:lnSpc>
@@ -13443,14 +13713,14 @@
                 <a:cs typeface="DM Sans Bold"/>
                 <a:sym typeface="DM Sans Bold"/>
               </a:rPr>
-              <a:t>A route back to today’s lesson.</a:t>
-            </a:r>
-          </a:p>
-        </p:txBody>
-      </p:sp>
-      <p:sp>
-        <p:nvSpPr>
-          <p:cNvPr name="TextBox 8" id="8"/>
+              <a:t>today’s lesson.</a:t>
+            </a:r>
+          </a:p>
+        </p:txBody>
+      </p:sp>
+      <p:sp>
+        <p:nvSpPr>
+          <p:cNvPr name="TextBox 9" id="9"/>
           <p:cNvSpPr txBox="true"/>
           <p:nvPr/>
         </p:nvSpPr>
@@ -13491,7 +13761,7 @@
       </p:sp>
       <p:sp>
         <p:nvSpPr>
-          <p:cNvPr name="TextBox 9" id="9"/>
+          <p:cNvPr name="TextBox 10" id="10"/>
           <p:cNvSpPr txBox="true"/>
           <p:nvPr/>
         </p:nvSpPr>
@@ -13532,7 +13802,7 @@
       </p:sp>
       <p:sp>
         <p:nvSpPr>
-          <p:cNvPr name="TextBox 10" id="10"/>
+          <p:cNvPr name="TextBox 11" id="11"/>
           <p:cNvSpPr txBox="true"/>
           <p:nvPr/>
         </p:nvSpPr>
@@ -13570,45 +13840,6 @@
             </a:r>
           </a:p>
         </p:txBody>
-      </p:sp>
-      <p:sp>
-        <p:nvSpPr>
-          <p:cNvPr name="Freeform 11" id="11"/>
-          <p:cNvSpPr/>
-          <p:nvPr/>
-        </p:nvSpPr>
-        <p:spPr>
-          <a:xfrm>
-            <a:off x="1714500" y="3714750"/>
-            <a:ext cx="8763000" cy="914864"/>
-          </a:xfrm>
-          <a:custGeom>
-            <a:avLst/>
-            <a:gdLst/>
-            <a:ahLst/>
-            <a:cxnLst/>
-            <a:rect r="r" b="b" t="t" l="l"/>
-            <a:pathLst>
-              <a:path h="914864" w="8763000">
-                <a:moveTo>
-                  <a:pt x="0" y="0"/>
-                </a:moveTo>
-                <a:quadBezTo>
-                  <a:pt x="4381500" y="1829728"/>
-                  <a:pt x="8763000" y="0"/>
-                </a:quadBezTo>
-              </a:path>
-            </a:pathLst>
-          </a:custGeom>
-          <a:ln cap="rnd" w="66675">
-            <a:solidFill>
-              <a:srgbClr val="C96331"/>
-            </a:solidFill>
-            <a:prstDash val="solid"/>
-            <a:headEnd type="oval" len="lg" w="lg"/>
-            <a:tailEnd type="arrow" len="sm" w="med"/>
-          </a:ln>
-        </p:spPr>
       </p:sp>
     </p:spTree>
   </p:cSld>
@@ -15158,7 +15389,7 @@
         <p:spPr>
           <a:xfrm rot="0">
             <a:off x="609600" y="3629025"/>
-            <a:ext cx="2286000" cy="337375"/>
+            <a:ext cx="2286000" cy="670751"/>
           </a:xfrm>
           <a:prstGeom prst="rect">
             <a:avLst/>
@@ -15169,6 +15400,25 @@
             <a:spAutoFit/>
           </a:bodyPr>
           <a:lstStyle/>
+          <a:p>
+            <a:pPr algn="ctr">
+              <a:lnSpc>
+                <a:spcPts val="2653"/>
+              </a:lnSpc>
+            </a:pPr>
+            <a:r>
+              <a:rPr lang="en-US" sz="2175" b="true">
+                <a:solidFill>
+                  <a:srgbClr val="151521"/>
+                </a:solidFill>
+                <a:latin typeface="DM Sans Bold"/>
+                <a:ea typeface="DM Sans Bold"/>
+                <a:cs typeface="DM Sans Bold"/>
+                <a:sym typeface="DM Sans Bold"/>
+              </a:rPr>
+              <a:t>Try today’s</a:t>
+            </a:r>
+          </a:p>
           <a:p>
             <a:pPr algn="ctr">
               <a:lnSpc>
@@ -15185,7 +15435,7 @@
                 <a:cs typeface="DM Sans Bold"/>
                 <a:sym typeface="DM Sans Bold"/>
               </a:rPr>
-              <a:t>Try today’s task</a:t>
+              <a:t>task</a:t>
             </a:r>
           </a:p>
         </p:txBody>
@@ -15799,7 +16049,7 @@
         <p:spPr>
           <a:xfrm rot="0">
             <a:off x="6400800" y="3629025"/>
-            <a:ext cx="2286000" cy="1004125"/>
+            <a:ext cx="2286000" cy="670751"/>
           </a:xfrm>
           <a:prstGeom prst="rect">
             <a:avLst/>
@@ -15826,7 +16076,7 @@
                 <a:cs typeface="DM Sans Bold"/>
                 <a:sym typeface="DM Sans Bold"/>
               </a:rPr>
-              <a:t>Practice the step</a:t>
+              <a:t>Practice with</a:t>
             </a:r>
           </a:p>
           <a:p>
@@ -15845,7 +16095,7 @@
                 <a:cs typeface="DM Sans Bold"/>
                 <a:sym typeface="DM Sans Bold"/>
               </a:rPr>
-              <a:t>with Khan</a:t>
+              <a:t>Khan Academy</a:t>
             </a:r>
           </a:p>
         </p:txBody>
@@ -16352,7 +16602,458 @@
       </p:grpSp>
       <p:sp>
         <p:nvSpPr>
-          <p:cNvPr name="TextBox 5" id="5"/>
+          <p:cNvPr name="Freeform 5" id="5"/>
+          <p:cNvSpPr/>
+          <p:nvPr/>
+        </p:nvSpPr>
+        <p:spPr>
+          <a:xfrm flipH="false" flipV="false" rot="0">
+            <a:off x="609600" y="4762500"/>
+            <a:ext cx="10972800" cy="895350"/>
+          </a:xfrm>
+          <a:custGeom>
+            <a:avLst/>
+            <a:gdLst/>
+            <a:ahLst/>
+            <a:cxnLst/>
+            <a:rect r="r" b="b" t="t" l="l"/>
+            <a:pathLst>
+              <a:path h="895350" w="10972800">
+                <a:moveTo>
+                  <a:pt x="0" y="0"/>
+                </a:moveTo>
+                <a:lnTo>
+                  <a:pt x="10972800" y="0"/>
+                </a:lnTo>
+                <a:lnTo>
+                  <a:pt x="10972800" y="895350"/>
+                </a:lnTo>
+                <a:lnTo>
+                  <a:pt x="0" y="895350"/>
+                </a:lnTo>
+                <a:lnTo>
+                  <a:pt x="0" y="0"/>
+                </a:lnTo>
+                <a:close/>
+              </a:path>
+            </a:pathLst>
+          </a:custGeom>
+          <a:blipFill>
+            <a:blip r:embed="rId4">
+              <a:extLst>
+                <a:ext uri="{96DAC541-7B7A-43D3-8B79-37D633B846F1}">
+                  <asvg:svgBlip xmlns:asvg="http://schemas.microsoft.com/office/drawing/2016/SVG/main" r:embed="rId5"/>
+                </a:ext>
+              </a:extLst>
+            </a:blip>
+            <a:stretch>
+              <a:fillRect l="0" t="0" r="0" b="0"/>
+            </a:stretch>
+          </a:blipFill>
+        </p:spPr>
+      </p:sp>
+      <p:sp>
+        <p:nvSpPr>
+          <p:cNvPr name="AutoShape 6" id="6"/>
+          <p:cNvSpPr/>
+          <p:nvPr/>
+        </p:nvSpPr>
+        <p:spPr>
+          <a:xfrm>
+            <a:off x="609600" y="1381125"/>
+            <a:ext cx="10972800" cy="0"/>
+          </a:xfrm>
+          <a:prstGeom prst="line">
+            <a:avLst/>
+          </a:prstGeom>
+          <a:ln cap="flat" w="19050">
+            <a:solidFill>
+              <a:srgbClr val="CCD7E4"/>
+            </a:solidFill>
+            <a:prstDash val="solid"/>
+            <a:headEnd type="none" len="sm" w="sm"/>
+            <a:tailEnd type="none" len="sm" w="sm"/>
+          </a:ln>
+        </p:spPr>
+      </p:sp>
+      <p:grpSp>
+        <p:nvGrpSpPr>
+          <p:cNvPr name="Group 7" id="7"/>
+          <p:cNvGrpSpPr/>
+          <p:nvPr/>
+        </p:nvGrpSpPr>
+        <p:grpSpPr>
+          <a:xfrm rot="0">
+            <a:off x="609600" y="2571750"/>
+            <a:ext cx="5029200" cy="2190750"/>
+            <a:chOff x="0" y="0"/>
+            <a:chExt cx="1986844" cy="865481"/>
+          </a:xfrm>
+        </p:grpSpPr>
+        <p:sp>
+          <p:nvSpPr>
+            <p:cNvPr name="Freeform 8" id="8"/>
+            <p:cNvSpPr/>
+            <p:nvPr/>
+          </p:nvSpPr>
+          <p:spPr>
+            <a:xfrm flipH="false" flipV="false" rot="0">
+              <a:off x="0" y="0"/>
+              <a:ext cx="1986844" cy="865481"/>
+            </a:xfrm>
+            <a:custGeom>
+              <a:avLst/>
+              <a:gdLst/>
+              <a:ahLst/>
+              <a:cxnLst/>
+              <a:rect r="r" b="b" t="t" l="l"/>
+              <a:pathLst>
+                <a:path h="865481" w="1986844">
+                  <a:moveTo>
+                    <a:pt x="18473" y="0"/>
+                  </a:moveTo>
+                  <a:lnTo>
+                    <a:pt x="1968372" y="0"/>
+                  </a:lnTo>
+                  <a:cubicBezTo>
+                    <a:pt x="1973271" y="0"/>
+                    <a:pt x="1977970" y="1946"/>
+                    <a:pt x="1981434" y="5411"/>
+                  </a:cubicBezTo>
+                  <a:cubicBezTo>
+                    <a:pt x="1984898" y="8875"/>
+                    <a:pt x="1986844" y="13573"/>
+                    <a:pt x="1986844" y="18473"/>
+                  </a:cubicBezTo>
+                  <a:lnTo>
+                    <a:pt x="1986844" y="847009"/>
+                  </a:lnTo>
+                  <a:cubicBezTo>
+                    <a:pt x="1986844" y="851908"/>
+                    <a:pt x="1984898" y="856607"/>
+                    <a:pt x="1981434" y="860071"/>
+                  </a:cubicBezTo>
+                  <a:cubicBezTo>
+                    <a:pt x="1977970" y="863535"/>
+                    <a:pt x="1973271" y="865481"/>
+                    <a:pt x="1968372" y="865481"/>
+                  </a:cubicBezTo>
+                  <a:lnTo>
+                    <a:pt x="18473" y="865481"/>
+                  </a:lnTo>
+                  <a:cubicBezTo>
+                    <a:pt x="13573" y="865481"/>
+                    <a:pt x="8875" y="863535"/>
+                    <a:pt x="5411" y="860071"/>
+                  </a:cubicBezTo>
+                  <a:cubicBezTo>
+                    <a:pt x="1946" y="856607"/>
+                    <a:pt x="0" y="851908"/>
+                    <a:pt x="0" y="847009"/>
+                  </a:cubicBezTo>
+                  <a:lnTo>
+                    <a:pt x="0" y="18473"/>
+                  </a:lnTo>
+                  <a:cubicBezTo>
+                    <a:pt x="0" y="13573"/>
+                    <a:pt x="1946" y="8875"/>
+                    <a:pt x="5411" y="5411"/>
+                  </a:cubicBezTo>
+                  <a:cubicBezTo>
+                    <a:pt x="8875" y="1946"/>
+                    <a:pt x="13573" y="0"/>
+                    <a:pt x="18473" y="0"/>
+                  </a:cubicBezTo>
+                  <a:close/>
+                </a:path>
+              </a:pathLst>
+            </a:custGeom>
+            <a:solidFill>
+              <a:srgbClr val="D9F2EA"/>
+            </a:solidFill>
+          </p:spPr>
+        </p:sp>
+        <p:sp>
+          <p:nvSpPr>
+            <p:cNvPr name="TextBox 9" id="9"/>
+            <p:cNvSpPr txBox="true"/>
+            <p:nvPr/>
+          </p:nvSpPr>
+          <p:spPr>
+            <a:xfrm>
+              <a:off x="0" y="0"/>
+              <a:ext cx="1986844" cy="865481"/>
+            </a:xfrm>
+            <a:prstGeom prst="rect">
+              <a:avLst/>
+            </a:prstGeom>
+          </p:spPr>
+          <p:txBody>
+            <a:bodyPr anchor="ctr" rtlCol="false" tIns="50800" lIns="50800" bIns="50800" rIns="50800"/>
+            <a:lstStyle/>
+            <a:p>
+              <a:pPr algn="ctr">
+                <a:lnSpc>
+                  <a:spcPts val="1372"/>
+                </a:lnSpc>
+              </a:pPr>
+            </a:p>
+          </p:txBody>
+        </p:sp>
+      </p:grpSp>
+      <p:grpSp>
+        <p:nvGrpSpPr>
+          <p:cNvPr name="Group 10" id="10"/>
+          <p:cNvGrpSpPr/>
+          <p:nvPr/>
+        </p:nvGrpSpPr>
+        <p:grpSpPr>
+          <a:xfrm rot="0">
+            <a:off x="6553200" y="2571750"/>
+            <a:ext cx="5029200" cy="2190750"/>
+            <a:chOff x="0" y="0"/>
+            <a:chExt cx="1986844" cy="865481"/>
+          </a:xfrm>
+        </p:grpSpPr>
+        <p:sp>
+          <p:nvSpPr>
+            <p:cNvPr name="Freeform 11" id="11"/>
+            <p:cNvSpPr/>
+            <p:nvPr/>
+          </p:nvSpPr>
+          <p:spPr>
+            <a:xfrm flipH="false" flipV="false" rot="0">
+              <a:off x="0" y="0"/>
+              <a:ext cx="1986844" cy="865481"/>
+            </a:xfrm>
+            <a:custGeom>
+              <a:avLst/>
+              <a:gdLst/>
+              <a:ahLst/>
+              <a:cxnLst/>
+              <a:rect r="r" b="b" t="t" l="l"/>
+              <a:pathLst>
+                <a:path h="865481" w="1986844">
+                  <a:moveTo>
+                    <a:pt x="18473" y="0"/>
+                  </a:moveTo>
+                  <a:lnTo>
+                    <a:pt x="1968372" y="0"/>
+                  </a:lnTo>
+                  <a:cubicBezTo>
+                    <a:pt x="1973271" y="0"/>
+                    <a:pt x="1977970" y="1946"/>
+                    <a:pt x="1981434" y="5411"/>
+                  </a:cubicBezTo>
+                  <a:cubicBezTo>
+                    <a:pt x="1984898" y="8875"/>
+                    <a:pt x="1986844" y="13573"/>
+                    <a:pt x="1986844" y="18473"/>
+                  </a:cubicBezTo>
+                  <a:lnTo>
+                    <a:pt x="1986844" y="847009"/>
+                  </a:lnTo>
+                  <a:cubicBezTo>
+                    <a:pt x="1986844" y="851908"/>
+                    <a:pt x="1984898" y="856607"/>
+                    <a:pt x="1981434" y="860071"/>
+                  </a:cubicBezTo>
+                  <a:cubicBezTo>
+                    <a:pt x="1977970" y="863535"/>
+                    <a:pt x="1973271" y="865481"/>
+                    <a:pt x="1968372" y="865481"/>
+                  </a:cubicBezTo>
+                  <a:lnTo>
+                    <a:pt x="18473" y="865481"/>
+                  </a:lnTo>
+                  <a:cubicBezTo>
+                    <a:pt x="13573" y="865481"/>
+                    <a:pt x="8875" y="863535"/>
+                    <a:pt x="5411" y="860071"/>
+                  </a:cubicBezTo>
+                  <a:cubicBezTo>
+                    <a:pt x="1946" y="856607"/>
+                    <a:pt x="0" y="851908"/>
+                    <a:pt x="0" y="847009"/>
+                  </a:cubicBezTo>
+                  <a:lnTo>
+                    <a:pt x="0" y="18473"/>
+                  </a:lnTo>
+                  <a:cubicBezTo>
+                    <a:pt x="0" y="13573"/>
+                    <a:pt x="1946" y="8875"/>
+                    <a:pt x="5411" y="5411"/>
+                  </a:cubicBezTo>
+                  <a:cubicBezTo>
+                    <a:pt x="8875" y="1946"/>
+                    <a:pt x="13573" y="0"/>
+                    <a:pt x="18473" y="0"/>
+                  </a:cubicBezTo>
+                  <a:close/>
+                </a:path>
+              </a:pathLst>
+            </a:custGeom>
+            <a:solidFill>
+              <a:srgbClr val="F8EADF"/>
+            </a:solidFill>
+          </p:spPr>
+        </p:sp>
+        <p:sp>
+          <p:nvSpPr>
+            <p:cNvPr name="TextBox 12" id="12"/>
+            <p:cNvSpPr txBox="true"/>
+            <p:nvPr/>
+          </p:nvSpPr>
+          <p:spPr>
+            <a:xfrm>
+              <a:off x="0" y="0"/>
+              <a:ext cx="1986844" cy="865481"/>
+            </a:xfrm>
+            <a:prstGeom prst="rect">
+              <a:avLst/>
+            </a:prstGeom>
+          </p:spPr>
+          <p:txBody>
+            <a:bodyPr anchor="ctr" rtlCol="false" tIns="50800" lIns="50800" bIns="50800" rIns="50800"/>
+            <a:lstStyle/>
+            <a:p>
+              <a:pPr algn="ctr">
+                <a:lnSpc>
+                  <a:spcPts val="1372"/>
+                </a:lnSpc>
+              </a:pPr>
+            </a:p>
+          </p:txBody>
+        </p:sp>
+      </p:grpSp>
+      <p:grpSp>
+        <p:nvGrpSpPr>
+          <p:cNvPr name="Group 13" id="13"/>
+          <p:cNvGrpSpPr/>
+          <p:nvPr/>
+        </p:nvGrpSpPr>
+        <p:grpSpPr>
+          <a:xfrm rot="0">
+            <a:off x="3429000" y="5619750"/>
+            <a:ext cx="5334000" cy="809625"/>
+            <a:chOff x="0" y="0"/>
+            <a:chExt cx="2107259" cy="319852"/>
+          </a:xfrm>
+        </p:grpSpPr>
+        <p:sp>
+          <p:nvSpPr>
+            <p:cNvPr name="Freeform 14" id="14"/>
+            <p:cNvSpPr/>
+            <p:nvPr/>
+          </p:nvSpPr>
+          <p:spPr>
+            <a:xfrm flipH="false" flipV="false" rot="0">
+              <a:off x="0" y="0"/>
+              <a:ext cx="2107259" cy="319852"/>
+            </a:xfrm>
+            <a:custGeom>
+              <a:avLst/>
+              <a:gdLst/>
+              <a:ahLst/>
+              <a:cxnLst/>
+              <a:rect r="r" b="b" t="t" l="l"/>
+              <a:pathLst>
+                <a:path h="319852" w="2107259">
+                  <a:moveTo>
+                    <a:pt x="17417" y="0"/>
+                  </a:moveTo>
+                  <a:lnTo>
+                    <a:pt x="2089842" y="0"/>
+                  </a:lnTo>
+                  <a:cubicBezTo>
+                    <a:pt x="2094461" y="0"/>
+                    <a:pt x="2098891" y="1835"/>
+                    <a:pt x="2102158" y="5101"/>
+                  </a:cubicBezTo>
+                  <a:cubicBezTo>
+                    <a:pt x="2105424" y="8368"/>
+                    <a:pt x="2107259" y="12798"/>
+                    <a:pt x="2107259" y="17417"/>
+                  </a:cubicBezTo>
+                  <a:lnTo>
+                    <a:pt x="2107259" y="302435"/>
+                  </a:lnTo>
+                  <a:cubicBezTo>
+                    <a:pt x="2107259" y="307054"/>
+                    <a:pt x="2105424" y="311484"/>
+                    <a:pt x="2102158" y="314750"/>
+                  </a:cubicBezTo>
+                  <a:cubicBezTo>
+                    <a:pt x="2098891" y="318017"/>
+                    <a:pt x="2094461" y="319852"/>
+                    <a:pt x="2089842" y="319852"/>
+                  </a:cubicBezTo>
+                  <a:lnTo>
+                    <a:pt x="17417" y="319852"/>
+                  </a:lnTo>
+                  <a:cubicBezTo>
+                    <a:pt x="12798" y="319852"/>
+                    <a:pt x="8368" y="318017"/>
+                    <a:pt x="5101" y="314750"/>
+                  </a:cubicBezTo>
+                  <a:cubicBezTo>
+                    <a:pt x="1835" y="311484"/>
+                    <a:pt x="0" y="307054"/>
+                    <a:pt x="0" y="302435"/>
+                  </a:cubicBezTo>
+                  <a:lnTo>
+                    <a:pt x="0" y="17417"/>
+                  </a:lnTo>
+                  <a:cubicBezTo>
+                    <a:pt x="0" y="12798"/>
+                    <a:pt x="1835" y="8368"/>
+                    <a:pt x="5101" y="5101"/>
+                  </a:cubicBezTo>
+                  <a:cubicBezTo>
+                    <a:pt x="8368" y="1835"/>
+                    <a:pt x="12798" y="0"/>
+                    <a:pt x="17417" y="0"/>
+                  </a:cubicBezTo>
+                  <a:close/>
+                </a:path>
+              </a:pathLst>
+            </a:custGeom>
+            <a:solidFill>
+              <a:srgbClr val="F0EFFF"/>
+            </a:solidFill>
+          </p:spPr>
+        </p:sp>
+        <p:sp>
+          <p:nvSpPr>
+            <p:cNvPr name="TextBox 15" id="15"/>
+            <p:cNvSpPr txBox="true"/>
+            <p:nvPr/>
+          </p:nvSpPr>
+          <p:spPr>
+            <a:xfrm>
+              <a:off x="0" y="0"/>
+              <a:ext cx="2107259" cy="319852"/>
+            </a:xfrm>
+            <a:prstGeom prst="rect">
+              <a:avLst/>
+            </a:prstGeom>
+          </p:spPr>
+          <p:txBody>
+            <a:bodyPr anchor="ctr" rtlCol="false" tIns="50800" lIns="50800" bIns="50800" rIns="50800"/>
+            <a:lstStyle/>
+            <a:p>
+              <a:pPr algn="ctr">
+                <a:lnSpc>
+                  <a:spcPts val="1372"/>
+                </a:lnSpc>
+              </a:pPr>
+            </a:p>
+          </p:txBody>
+        </p:sp>
+      </p:grpSp>
+      <p:sp>
+        <p:nvSpPr>
+          <p:cNvPr name="TextBox 16" id="16"/>
           <p:cNvSpPr txBox="true"/>
           <p:nvPr/>
         </p:nvSpPr>
@@ -16393,7 +17094,7 @@
       </p:sp>
       <p:sp>
         <p:nvSpPr>
-          <p:cNvPr name="TextBox 6" id="6"/>
+          <p:cNvPr name="TextBox 17" id="17"/>
           <p:cNvSpPr txBox="true"/>
           <p:nvPr/>
         </p:nvSpPr>
@@ -16434,14 +17135,14 @@
       </p:sp>
       <p:sp>
         <p:nvSpPr>
-          <p:cNvPr name="TextBox 7" id="7"/>
+          <p:cNvPr name="TextBox 18" id="18"/>
           <p:cNvSpPr txBox="true"/>
           <p:nvPr/>
         </p:nvSpPr>
         <p:spPr>
           <a:xfrm rot="0">
-            <a:off x="609600" y="2505075"/>
-            <a:ext cx="3190875" cy="393573"/>
+            <a:off x="609600" y="1609725"/>
+            <a:ext cx="10972800" cy="459105"/>
           </a:xfrm>
           <a:prstGeom prst="rect">
             <a:avLst/>
@@ -16453,218 +17154,36 @@
           </a:bodyPr>
           <a:lstStyle/>
           <a:p>
-            <a:pPr algn="l">
+            <a:pPr algn="ctr">
               <a:lnSpc>
-                <a:spcPts val="3111"/>
+                <a:spcPts val="3660"/>
               </a:lnSpc>
             </a:pPr>
             <a:r>
-              <a:rPr lang="en-US" b="true" sz="2550">
+              <a:rPr lang="en-US" b="true" sz="3000">
                 <a:solidFill>
-                  <a:srgbClr val="087E70"/>
+                  <a:srgbClr val="151521"/>
                 </a:solidFill>
                 <a:latin typeface="DM Sans Bold"/>
                 <a:ea typeface="DM Sans Bold"/>
                 <a:cs typeface="DM Sans Bold"/>
                 <a:sym typeface="DM Sans Bold"/>
               </a:rPr>
-              <a:t>Tried x = 3, 4</a:t>
-            </a:r>
-          </a:p>
-        </p:txBody>
-      </p:sp>
-      <p:sp>
-        <p:nvSpPr>
-          <p:cNvPr name="AutoShape 8" id="8"/>
-          <p:cNvSpPr/>
-          <p:nvPr/>
-        </p:nvSpPr>
-        <p:spPr>
-          <a:xfrm rot="0">
-            <a:off x="3762375" y="2724150"/>
-            <a:ext cx="1428750" cy="38100"/>
-          </a:xfrm>
-          <a:prstGeom prst="rect">
-            <a:avLst/>
-          </a:prstGeom>
-          <a:solidFill>
-            <a:srgbClr val="087E70"/>
-          </a:solidFill>
-        </p:spPr>
-      </p:sp>
-      <p:grpSp>
-        <p:nvGrpSpPr>
-          <p:cNvPr name="Group 9" id="9"/>
-          <p:cNvGrpSpPr/>
-          <p:nvPr/>
-        </p:nvGrpSpPr>
-        <p:grpSpPr>
-          <a:xfrm rot="1840140">
-            <a:off x="5133308" y="2688526"/>
-            <a:ext cx="171450" cy="28575"/>
-            <a:chOff x="0" y="0"/>
-            <a:chExt cx="228600" cy="38100"/>
-          </a:xfrm>
-        </p:grpSpPr>
-        <p:sp>
-          <p:nvSpPr>
-            <p:cNvPr name="Freeform 10" id="10"/>
-            <p:cNvSpPr/>
-            <p:nvPr/>
-          </p:nvSpPr>
-          <p:spPr>
-            <a:xfrm flipH="false" flipV="false" rot="0">
-              <a:off x="0" y="0"/>
-              <a:ext cx="228600" cy="38100"/>
-            </a:xfrm>
-            <a:custGeom>
-              <a:avLst/>
-              <a:gdLst/>
-              <a:ahLst/>
-              <a:cxnLst/>
-              <a:rect r="r" b="b" t="t" l="l"/>
-              <a:pathLst>
-                <a:path h="38100" w="228600">
-                  <a:moveTo>
-                    <a:pt x="19050" y="0"/>
-                  </a:moveTo>
-                  <a:lnTo>
-                    <a:pt x="209550" y="0"/>
-                  </a:lnTo>
-                  <a:cubicBezTo>
-                    <a:pt x="220091" y="0"/>
-                    <a:pt x="228600" y="8509"/>
-                    <a:pt x="228600" y="19050"/>
-                  </a:cubicBezTo>
-                  <a:cubicBezTo>
-                    <a:pt x="228600" y="29591"/>
-                    <a:pt x="220091" y="38100"/>
-                    <a:pt x="209550" y="38100"/>
-                  </a:cubicBezTo>
-                  <a:lnTo>
-                    <a:pt x="19050" y="38100"/>
-                  </a:lnTo>
-                  <a:cubicBezTo>
-                    <a:pt x="8509" y="38100"/>
-                    <a:pt x="0" y="29591"/>
-                    <a:pt x="0" y="19050"/>
-                  </a:cubicBezTo>
-                  <a:cubicBezTo>
-                    <a:pt x="0" y="8509"/>
-                    <a:pt x="8509" y="0"/>
-                    <a:pt x="19050" y="0"/>
-                  </a:cubicBezTo>
-                  <a:close/>
-                </a:path>
-              </a:pathLst>
-            </a:custGeom>
-            <a:solidFill>
-              <a:srgbClr val="087E70"/>
-            </a:solidFill>
-          </p:spPr>
-        </p:sp>
-      </p:grpSp>
-      <p:grpSp>
-        <p:nvGrpSpPr>
-          <p:cNvPr name="Group 11" id="11"/>
-          <p:cNvGrpSpPr/>
-          <p:nvPr/>
-        </p:nvGrpSpPr>
-        <p:grpSpPr>
-          <a:xfrm rot="8959860">
-            <a:off x="5125212" y="2774252"/>
-            <a:ext cx="171450" cy="28575"/>
-            <a:chOff x="0" y="0"/>
-            <a:chExt cx="228600" cy="38100"/>
-          </a:xfrm>
-        </p:grpSpPr>
-        <p:sp>
-          <p:nvSpPr>
-            <p:cNvPr name="Freeform 12" id="12"/>
-            <p:cNvSpPr/>
-            <p:nvPr/>
-          </p:nvSpPr>
-          <p:spPr>
-            <a:xfrm flipH="false" flipV="false" rot="0">
-              <a:off x="0" y="0"/>
-              <a:ext cx="228600" cy="38100"/>
-            </a:xfrm>
-            <a:custGeom>
-              <a:avLst/>
-              <a:gdLst/>
-              <a:ahLst/>
-              <a:cxnLst/>
-              <a:rect r="r" b="b" t="t" l="l"/>
-              <a:pathLst>
-                <a:path h="38100" w="228600">
-                  <a:moveTo>
-                    <a:pt x="19050" y="0"/>
-                  </a:moveTo>
-                  <a:lnTo>
-                    <a:pt x="209550" y="0"/>
-                  </a:lnTo>
-                  <a:cubicBezTo>
-                    <a:pt x="220091" y="0"/>
-                    <a:pt x="228600" y="8509"/>
-                    <a:pt x="228600" y="19050"/>
-                  </a:cubicBezTo>
-                  <a:cubicBezTo>
-                    <a:pt x="228600" y="29591"/>
-                    <a:pt x="220091" y="38100"/>
-                    <a:pt x="209550" y="38100"/>
-                  </a:cubicBezTo>
-                  <a:lnTo>
-                    <a:pt x="19050" y="38100"/>
-                  </a:lnTo>
-                  <a:cubicBezTo>
-                    <a:pt x="8509" y="38100"/>
-                    <a:pt x="0" y="29591"/>
-                    <a:pt x="0" y="19050"/>
-                  </a:cubicBezTo>
-                  <a:cubicBezTo>
-                    <a:pt x="0" y="8509"/>
-                    <a:pt x="8509" y="0"/>
-                    <a:pt x="19050" y="0"/>
-                  </a:cubicBezTo>
-                  <a:close/>
-                </a:path>
-              </a:pathLst>
-            </a:custGeom>
-            <a:solidFill>
-              <a:srgbClr val="087E70"/>
-            </a:solidFill>
-          </p:spPr>
-        </p:sp>
-      </p:grpSp>
-      <p:sp>
-        <p:nvSpPr>
-          <p:cNvPr name="AutoShape 13" id="13"/>
-          <p:cNvSpPr/>
-          <p:nvPr/>
-        </p:nvSpPr>
-        <p:spPr>
-          <a:xfrm rot="0">
-            <a:off x="5610225" y="2286000"/>
-            <a:ext cx="5972175" cy="942975"/>
-          </a:xfrm>
-          <a:prstGeom prst="rect">
-            <a:avLst/>
-          </a:prstGeom>
-          <a:solidFill>
-            <a:srgbClr val="D9F2EA"/>
-          </a:solidFill>
-        </p:spPr>
-      </p:sp>
-      <p:sp>
-        <p:nvSpPr>
-          <p:cNvPr name="TextBox 14" id="14"/>
+              <a:t>For x² + 7x + 12 = 0</a:t>
+            </a:r>
+          </a:p>
+        </p:txBody>
+      </p:sp>
+      <p:sp>
+        <p:nvSpPr>
+          <p:cNvPr name="TextBox 19" id="19"/>
           <p:cNvSpPr txBox="true"/>
           <p:nvPr/>
         </p:nvSpPr>
         <p:spPr>
           <a:xfrm rot="0">
-            <a:off x="5810250" y="2495550"/>
-            <a:ext cx="5572125" cy="430911"/>
+            <a:off x="838200" y="2857500"/>
+            <a:ext cx="4572000" cy="506222"/>
           </a:xfrm>
           <a:prstGeom prst="rect">
             <a:avLst/>
@@ -16678,34 +17197,37 @@
           <a:p>
             <a:pPr algn="ctr">
               <a:lnSpc>
-                <a:spcPts val="3476"/>
+                <a:spcPts val="3904"/>
               </a:lnSpc>
+              <a:spcBef>
+                <a:spcPct val="0"/>
+              </a:spcBef>
             </a:pPr>
             <a:r>
-              <a:rPr lang="en-US" b="true" sz="2850">
+              <a:rPr lang="en-US" b="true" sz="3200">
                 <a:solidFill>
-                  <a:srgbClr val="087E70"/>
+                  <a:srgbClr val="151521"/>
                 </a:solidFill>
                 <a:latin typeface="DM Sans Bold"/>
                 <a:ea typeface="DM Sans Bold"/>
                 <a:cs typeface="DM Sans Bold"/>
                 <a:sym typeface="DM Sans Bold"/>
               </a:rPr>
-              <a:t>Check signs → fresh goal</a:t>
-            </a:r>
-          </a:p>
-        </p:txBody>
-      </p:sp>
-      <p:sp>
-        <p:nvSpPr>
-          <p:cNvPr name="TextBox 15" id="15"/>
+              <a:t>x = 3, 4</a:t>
+            </a:r>
+          </a:p>
+        </p:txBody>
+      </p:sp>
+      <p:sp>
+        <p:nvSpPr>
+          <p:cNvPr name="TextBox 20" id="20"/>
           <p:cNvSpPr txBox="true"/>
           <p:nvPr/>
         </p:nvSpPr>
         <p:spPr>
           <a:xfrm rot="0">
-            <a:off x="609600" y="4162425"/>
-            <a:ext cx="2857500" cy="393573"/>
+            <a:off x="838200" y="3762375"/>
+            <a:ext cx="4572000" cy="547878"/>
           </a:xfrm>
           <a:prstGeom prst="rect">
             <a:avLst/>
@@ -16717,441 +17239,58 @@
           </a:bodyPr>
           <a:lstStyle/>
           <a:p>
-            <a:pPr algn="l">
+            <a:pPr algn="ctr">
               <a:lnSpc>
-                <a:spcPts val="3111"/>
+                <a:spcPts val="2196"/>
               </a:lnSpc>
             </a:pPr>
             <a:r>
-              <a:rPr lang="en-US" b="true" sz="2550">
+              <a:rPr lang="en-US" b="true" sz="1800">
                 <a:solidFill>
-                  <a:srgbClr val="C96331"/>
+                  <a:srgbClr val="536073"/>
                 </a:solidFill>
                 <a:latin typeface="DM Sans Bold"/>
                 <a:ea typeface="DM Sans Bold"/>
                 <a:cs typeface="DM Sans Bold"/>
                 <a:sym typeface="DM Sans Bold"/>
               </a:rPr>
-              <a:t>Tried x = 2, 6</a:t>
-            </a:r>
-          </a:p>
-        </p:txBody>
-      </p:sp>
-      <p:sp>
-        <p:nvSpPr>
-          <p:cNvPr name="AutoShape 16" id="16"/>
-          <p:cNvSpPr/>
-          <p:nvPr/>
-        </p:nvSpPr>
-        <p:spPr>
-          <a:xfrm rot="0">
-            <a:off x="3495675" y="4410075"/>
-            <a:ext cx="1019175" cy="38100"/>
-          </a:xfrm>
-          <a:prstGeom prst="rect">
-            <a:avLst/>
-          </a:prstGeom>
-          <a:solidFill>
-            <a:srgbClr val="C96331"/>
-          </a:solidFill>
-        </p:spPr>
-      </p:sp>
-      <p:grpSp>
-        <p:nvGrpSpPr>
-          <p:cNvPr name="Group 17" id="17"/>
-          <p:cNvGrpSpPr/>
-          <p:nvPr/>
-        </p:nvGrpSpPr>
-        <p:grpSpPr>
-          <a:xfrm rot="1840140">
-            <a:off x="4457033" y="4374452"/>
-            <a:ext cx="171450" cy="28575"/>
-            <a:chOff x="0" y="0"/>
-            <a:chExt cx="228600" cy="38100"/>
-          </a:xfrm>
-        </p:grpSpPr>
-        <p:sp>
-          <p:nvSpPr>
-            <p:cNvPr name="Freeform 18" id="18"/>
-            <p:cNvSpPr/>
-            <p:nvPr/>
-          </p:nvSpPr>
-          <p:spPr>
-            <a:xfrm flipH="false" flipV="false" rot="0">
-              <a:off x="0" y="0"/>
-              <a:ext cx="228600" cy="38100"/>
-            </a:xfrm>
-            <a:custGeom>
-              <a:avLst/>
-              <a:gdLst/>
-              <a:ahLst/>
-              <a:cxnLst/>
-              <a:rect r="r" b="b" t="t" l="l"/>
-              <a:pathLst>
-                <a:path h="38100" w="228600">
-                  <a:moveTo>
-                    <a:pt x="19050" y="0"/>
-                  </a:moveTo>
-                  <a:lnTo>
-                    <a:pt x="209550" y="0"/>
-                  </a:lnTo>
-                  <a:cubicBezTo>
-                    <a:pt x="220091" y="0"/>
-                    <a:pt x="228600" y="8509"/>
-                    <a:pt x="228600" y="19050"/>
-                  </a:cubicBezTo>
-                  <a:cubicBezTo>
-                    <a:pt x="228600" y="29591"/>
-                    <a:pt x="220091" y="38100"/>
-                    <a:pt x="209550" y="38100"/>
-                  </a:cubicBezTo>
-                  <a:lnTo>
-                    <a:pt x="19050" y="38100"/>
-                  </a:lnTo>
-                  <a:cubicBezTo>
-                    <a:pt x="8509" y="38100"/>
-                    <a:pt x="0" y="29591"/>
-                    <a:pt x="0" y="19050"/>
-                  </a:cubicBezTo>
-                  <a:cubicBezTo>
-                    <a:pt x="0" y="8509"/>
-                    <a:pt x="8509" y="0"/>
-                    <a:pt x="19050" y="0"/>
-                  </a:cubicBezTo>
-                  <a:close/>
-                </a:path>
-              </a:pathLst>
-            </a:custGeom>
-            <a:solidFill>
-              <a:srgbClr val="C96331"/>
-            </a:solidFill>
-          </p:spPr>
-        </p:sp>
-      </p:grpSp>
-      <p:grpSp>
-        <p:nvGrpSpPr>
-          <p:cNvPr name="Group 19" id="19"/>
-          <p:cNvGrpSpPr/>
-          <p:nvPr/>
-        </p:nvGrpSpPr>
-        <p:grpSpPr>
-          <a:xfrm rot="8959860">
-            <a:off x="4448937" y="4460176"/>
-            <a:ext cx="171450" cy="28575"/>
-            <a:chOff x="0" y="0"/>
-            <a:chExt cx="228600" cy="38100"/>
-          </a:xfrm>
-        </p:grpSpPr>
-        <p:sp>
-          <p:nvSpPr>
-            <p:cNvPr name="Freeform 20" id="20"/>
-            <p:cNvSpPr/>
-            <p:nvPr/>
-          </p:nvSpPr>
-          <p:spPr>
-            <a:xfrm flipH="false" flipV="false" rot="0">
-              <a:off x="0" y="0"/>
-              <a:ext cx="228600" cy="38100"/>
-            </a:xfrm>
-            <a:custGeom>
-              <a:avLst/>
-              <a:gdLst/>
-              <a:ahLst/>
-              <a:cxnLst/>
-              <a:rect r="r" b="b" t="t" l="l"/>
-              <a:pathLst>
-                <a:path h="38100" w="228600">
-                  <a:moveTo>
-                    <a:pt x="19050" y="0"/>
-                  </a:moveTo>
-                  <a:lnTo>
-                    <a:pt x="209550" y="0"/>
-                  </a:lnTo>
-                  <a:cubicBezTo>
-                    <a:pt x="220091" y="0"/>
-                    <a:pt x="228600" y="8509"/>
-                    <a:pt x="228600" y="19050"/>
-                  </a:cubicBezTo>
-                  <a:cubicBezTo>
-                    <a:pt x="228600" y="29591"/>
-                    <a:pt x="220091" y="38100"/>
-                    <a:pt x="209550" y="38100"/>
-                  </a:cubicBezTo>
-                  <a:lnTo>
-                    <a:pt x="19050" y="38100"/>
-                  </a:lnTo>
-                  <a:cubicBezTo>
-                    <a:pt x="8509" y="38100"/>
-                    <a:pt x="0" y="29591"/>
-                    <a:pt x="0" y="19050"/>
-                  </a:cubicBezTo>
-                  <a:cubicBezTo>
-                    <a:pt x="0" y="8509"/>
-                    <a:pt x="8509" y="0"/>
-                    <a:pt x="19050" y="0"/>
-                  </a:cubicBezTo>
-                  <a:close/>
-                </a:path>
-              </a:pathLst>
-            </a:custGeom>
-            <a:solidFill>
-              <a:srgbClr val="C96331"/>
-            </a:solidFill>
-          </p:spPr>
-        </p:sp>
-      </p:grpSp>
-      <p:sp>
-        <p:nvSpPr>
-          <p:cNvPr name="AutoShape 21" id="21"/>
-          <p:cNvSpPr/>
-          <p:nvPr/>
-        </p:nvSpPr>
-        <p:spPr>
-          <a:xfrm rot="0">
-            <a:off x="4857750" y="3952875"/>
-            <a:ext cx="2914650" cy="971550"/>
-          </a:xfrm>
-          <a:prstGeom prst="rect">
-            <a:avLst/>
-          </a:prstGeom>
-          <a:solidFill>
-            <a:srgbClr val="F8EADF"/>
-          </a:solidFill>
-        </p:spPr>
-      </p:sp>
-      <p:sp>
-        <p:nvSpPr>
-          <p:cNvPr name="TextBox 22" id="22"/>
-          <p:cNvSpPr txBox="true"/>
-          <p:nvPr/>
-        </p:nvSpPr>
-        <p:spPr>
-          <a:xfrm rot="0">
-            <a:off x="5010150" y="4229100"/>
-            <a:ext cx="2609850" cy="346520"/>
-          </a:xfrm>
-          <a:prstGeom prst="rect">
-            <a:avLst/>
-          </a:prstGeom>
-        </p:spPr>
-        <p:txBody>
-          <a:bodyPr anchor="t" rtlCol="false" tIns="0" lIns="0" bIns="0" rIns="0">
-            <a:spAutoFit/>
-          </a:bodyPr>
-          <a:lstStyle/>
+              <a:t>Right pair, wrong signs.</a:t>
+            </a:r>
+          </a:p>
           <a:p>
             <a:pPr algn="ctr">
               <a:lnSpc>
-                <a:spcPts val="2836"/>
+                <a:spcPts val="2196"/>
               </a:lnSpc>
+              <a:spcBef>
+                <a:spcPct val="0"/>
+              </a:spcBef>
             </a:pPr>
             <a:r>
-              <a:rPr lang="en-US" b="true" sz="2325">
+              <a:rPr lang="en-US" b="true" sz="1800">
                 <a:solidFill>
-                  <a:srgbClr val="C96331"/>
+                  <a:srgbClr val="536073"/>
                 </a:solidFill>
                 <a:latin typeface="DM Sans Bold"/>
                 <a:ea typeface="DM Sans Bold"/>
                 <a:cs typeface="DM Sans Bold"/>
                 <a:sym typeface="DM Sans Bold"/>
               </a:rPr>
-              <a:t>Check factors</a:t>
-            </a:r>
-          </a:p>
-        </p:txBody>
-      </p:sp>
-      <p:sp>
-        <p:nvSpPr>
-          <p:cNvPr name="AutoShape 23" id="23"/>
-          <p:cNvSpPr/>
-          <p:nvPr/>
-        </p:nvSpPr>
-        <p:spPr>
-          <a:xfrm rot="0">
-            <a:off x="8029575" y="4410075"/>
-            <a:ext cx="771525" cy="38100"/>
-          </a:xfrm>
-          <a:prstGeom prst="rect">
-            <a:avLst/>
-          </a:prstGeom>
-          <a:solidFill>
-            <a:srgbClr val="C96331"/>
-          </a:solidFill>
-        </p:spPr>
-      </p:sp>
-      <p:grpSp>
-        <p:nvGrpSpPr>
-          <p:cNvPr name="Group 24" id="24"/>
-          <p:cNvGrpSpPr/>
-          <p:nvPr/>
-        </p:nvGrpSpPr>
-        <p:grpSpPr>
-          <a:xfrm rot="1840140">
-            <a:off x="8743283" y="4374452"/>
-            <a:ext cx="171450" cy="28575"/>
-            <a:chOff x="0" y="0"/>
-            <a:chExt cx="228600" cy="38100"/>
-          </a:xfrm>
-        </p:grpSpPr>
-        <p:sp>
-          <p:nvSpPr>
-            <p:cNvPr name="Freeform 25" id="25"/>
-            <p:cNvSpPr/>
-            <p:nvPr/>
-          </p:nvSpPr>
-          <p:spPr>
-            <a:xfrm flipH="false" flipV="false" rot="0">
-              <a:off x="0" y="0"/>
-              <a:ext cx="228600" cy="38100"/>
-            </a:xfrm>
-            <a:custGeom>
-              <a:avLst/>
-              <a:gdLst/>
-              <a:ahLst/>
-              <a:cxnLst/>
-              <a:rect r="r" b="b" t="t" l="l"/>
-              <a:pathLst>
-                <a:path h="38100" w="228600">
-                  <a:moveTo>
-                    <a:pt x="19050" y="0"/>
-                  </a:moveTo>
-                  <a:lnTo>
-                    <a:pt x="209550" y="0"/>
-                  </a:lnTo>
-                  <a:cubicBezTo>
-                    <a:pt x="220091" y="0"/>
-                    <a:pt x="228600" y="8509"/>
-                    <a:pt x="228600" y="19050"/>
-                  </a:cubicBezTo>
-                  <a:cubicBezTo>
-                    <a:pt x="228600" y="29591"/>
-                    <a:pt x="220091" y="38100"/>
-                    <a:pt x="209550" y="38100"/>
-                  </a:cubicBezTo>
-                  <a:lnTo>
-                    <a:pt x="19050" y="38100"/>
-                  </a:lnTo>
-                  <a:cubicBezTo>
-                    <a:pt x="8509" y="38100"/>
-                    <a:pt x="0" y="29591"/>
-                    <a:pt x="0" y="19050"/>
-                  </a:cubicBezTo>
-                  <a:cubicBezTo>
-                    <a:pt x="0" y="8509"/>
-                    <a:pt x="8509" y="0"/>
-                    <a:pt x="19050" y="0"/>
-                  </a:cubicBezTo>
-                  <a:close/>
-                </a:path>
-              </a:pathLst>
-            </a:custGeom>
-            <a:solidFill>
-              <a:srgbClr val="C96331"/>
-            </a:solidFill>
-          </p:spPr>
-        </p:sp>
-      </p:grpSp>
-      <p:grpSp>
-        <p:nvGrpSpPr>
-          <p:cNvPr name="Group 26" id="26"/>
-          <p:cNvGrpSpPr/>
-          <p:nvPr/>
-        </p:nvGrpSpPr>
-        <p:grpSpPr>
-          <a:xfrm rot="8959860">
-            <a:off x="8735187" y="4460176"/>
-            <a:ext cx="171450" cy="28575"/>
-            <a:chOff x="0" y="0"/>
-            <a:chExt cx="228600" cy="38100"/>
-          </a:xfrm>
-        </p:grpSpPr>
-        <p:sp>
-          <p:nvSpPr>
-            <p:cNvPr name="Freeform 27" id="27"/>
-            <p:cNvSpPr/>
-            <p:nvPr/>
-          </p:nvSpPr>
-          <p:spPr>
-            <a:xfrm flipH="false" flipV="false" rot="0">
-              <a:off x="0" y="0"/>
-              <a:ext cx="228600" cy="38100"/>
-            </a:xfrm>
-            <a:custGeom>
-              <a:avLst/>
-              <a:gdLst/>
-              <a:ahLst/>
-              <a:cxnLst/>
-              <a:rect r="r" b="b" t="t" l="l"/>
-              <a:pathLst>
-                <a:path h="38100" w="228600">
-                  <a:moveTo>
-                    <a:pt x="19050" y="0"/>
-                  </a:moveTo>
-                  <a:lnTo>
-                    <a:pt x="209550" y="0"/>
-                  </a:lnTo>
-                  <a:cubicBezTo>
-                    <a:pt x="220091" y="0"/>
-                    <a:pt x="228600" y="8509"/>
-                    <a:pt x="228600" y="19050"/>
-                  </a:cubicBezTo>
-                  <a:cubicBezTo>
-                    <a:pt x="228600" y="29591"/>
-                    <a:pt x="220091" y="38100"/>
-                    <a:pt x="209550" y="38100"/>
-                  </a:cubicBezTo>
-                  <a:lnTo>
-                    <a:pt x="19050" y="38100"/>
-                  </a:lnTo>
-                  <a:cubicBezTo>
-                    <a:pt x="8509" y="38100"/>
-                    <a:pt x="0" y="29591"/>
-                    <a:pt x="0" y="19050"/>
-                  </a:cubicBezTo>
-                  <a:cubicBezTo>
-                    <a:pt x="0" y="8509"/>
-                    <a:pt x="8509" y="0"/>
-                    <a:pt x="19050" y="0"/>
-                  </a:cubicBezTo>
-                  <a:close/>
-                </a:path>
-              </a:pathLst>
-            </a:custGeom>
-            <a:solidFill>
-              <a:srgbClr val="C96331"/>
-            </a:solidFill>
-          </p:spPr>
-        </p:sp>
-      </p:grpSp>
-      <p:sp>
-        <p:nvSpPr>
-          <p:cNvPr name="AutoShape 28" id="28"/>
-          <p:cNvSpPr/>
-          <p:nvPr/>
-        </p:nvSpPr>
-        <p:spPr>
-          <a:xfrm rot="0">
-            <a:off x="9144000" y="3952875"/>
-            <a:ext cx="2438400" cy="971550"/>
-          </a:xfrm>
-          <a:prstGeom prst="rect">
-            <a:avLst/>
-          </a:prstGeom>
-          <a:solidFill>
-            <a:srgbClr val="F0EFFF"/>
-          </a:solidFill>
-        </p:spPr>
-      </p:sp>
-      <p:sp>
-        <p:nvSpPr>
-          <p:cNvPr name="TextBox 29" id="29"/>
+              <a:t>Check signs and solutions.</a:t>
+            </a:r>
+          </a:p>
+        </p:txBody>
+      </p:sp>
+      <p:sp>
+        <p:nvSpPr>
+          <p:cNvPr name="TextBox 21" id="21"/>
           <p:cNvSpPr txBox="true"/>
           <p:nvPr/>
         </p:nvSpPr>
         <p:spPr>
           <a:xfrm rot="0">
-            <a:off x="9220200" y="4219575"/>
-            <a:ext cx="2286000" cy="346710"/>
+            <a:off x="6781800" y="2857500"/>
+            <a:ext cx="4572000" cy="506222"/>
           </a:xfrm>
           <a:prstGeom prst="rect">
             <a:avLst/>
@@ -17165,11 +17304,121 @@
           <a:p>
             <a:pPr algn="ctr">
               <a:lnSpc>
-                <a:spcPts val="2745"/>
+                <a:spcPts val="3904"/>
+              </a:lnSpc>
+              <a:spcBef>
+                <a:spcPct val="0"/>
+              </a:spcBef>
+            </a:pPr>
+            <a:r>
+              <a:rPr lang="en-US" b="true" sz="3200">
+                <a:solidFill>
+                  <a:srgbClr val="151521"/>
+                </a:solidFill>
+                <a:latin typeface="DM Sans Bold"/>
+                <a:ea typeface="DM Sans Bold"/>
+                <a:cs typeface="DM Sans Bold"/>
+                <a:sym typeface="DM Sans Bold"/>
+              </a:rPr>
+              <a:t>x = 2, 6</a:t>
+            </a:r>
+          </a:p>
+        </p:txBody>
+      </p:sp>
+      <p:sp>
+        <p:nvSpPr>
+          <p:cNvPr name="TextBox 22" id="22"/>
+          <p:cNvSpPr txBox="true"/>
+          <p:nvPr/>
+        </p:nvSpPr>
+        <p:spPr>
+          <a:xfrm rot="0">
+            <a:off x="6781800" y="3762375"/>
+            <a:ext cx="4572000" cy="547878"/>
+          </a:xfrm>
+          <a:prstGeom prst="rect">
+            <a:avLst/>
+          </a:prstGeom>
+        </p:spPr>
+        <p:txBody>
+          <a:bodyPr anchor="t" rtlCol="false" tIns="0" lIns="0" bIns="0" rIns="0">
+            <a:spAutoFit/>
+          </a:bodyPr>
+          <a:lstStyle/>
+          <a:p>
+            <a:pPr algn="ctr">
+              <a:lnSpc>
+                <a:spcPts val="2196"/>
               </a:lnSpc>
             </a:pPr>
             <a:r>
-              <a:rPr lang="en-US" b="true" sz="2250">
+              <a:rPr lang="en-US" b="true" sz="1800">
+                <a:solidFill>
+                  <a:srgbClr val="536073"/>
+                </a:solidFill>
+                <a:latin typeface="DM Sans Bold"/>
+                <a:ea typeface="DM Sans Bold"/>
+                <a:cs typeface="DM Sans Bold"/>
+                <a:sym typeface="DM Sans Bold"/>
+              </a:rPr>
+              <a:t>Wrong factor pair.</a:t>
+            </a:r>
+          </a:p>
+          <a:p>
+            <a:pPr algn="ctr">
+              <a:lnSpc>
+                <a:spcPts val="2196"/>
+              </a:lnSpc>
+              <a:spcBef>
+                <a:spcPct val="0"/>
+              </a:spcBef>
+            </a:pPr>
+            <a:r>
+              <a:rPr lang="en-US" b="true" sz="1800">
+                <a:solidFill>
+                  <a:srgbClr val="536073"/>
+                </a:solidFill>
+                <a:latin typeface="DM Sans Bold"/>
+                <a:ea typeface="DM Sans Bold"/>
+                <a:cs typeface="DM Sans Bold"/>
+                <a:sym typeface="DM Sans Bold"/>
+              </a:rPr>
+              <a:t>Check product and sum.</a:t>
+            </a:r>
+          </a:p>
+        </p:txBody>
+      </p:sp>
+      <p:sp>
+        <p:nvSpPr>
+          <p:cNvPr name="TextBox 23" id="23"/>
+          <p:cNvSpPr txBox="true"/>
+          <p:nvPr/>
+        </p:nvSpPr>
+        <p:spPr>
+          <a:xfrm rot="0">
+            <a:off x="3619500" y="5800725"/>
+            <a:ext cx="4953000" cy="374904"/>
+          </a:xfrm>
+          <a:prstGeom prst="rect">
+            <a:avLst/>
+          </a:prstGeom>
+        </p:spPr>
+        <p:txBody>
+          <a:bodyPr anchor="t" rtlCol="false" tIns="0" lIns="0" bIns="0" rIns="0">
+            <a:spAutoFit/>
+          </a:bodyPr>
+          <a:lstStyle/>
+          <a:p>
+            <a:pPr algn="ctr">
+              <a:lnSpc>
+                <a:spcPts val="2928"/>
+              </a:lnSpc>
+              <a:spcBef>
+                <a:spcPct val="0"/>
+              </a:spcBef>
+            </a:pPr>
+            <a:r>
+              <a:rPr lang="en-US" b="true" sz="2400">
                 <a:solidFill>
                   <a:srgbClr val="5753FA"/>
                 </a:solidFill>
@@ -17178,75 +17427,10 @@
                 <a:cs typeface="DM Sans Bold"/>
                 <a:sym typeface="DM Sans Bold"/>
               </a:rPr>
-              <a:t>Fresh goal</a:t>
-            </a:r>
-          </a:p>
-        </p:txBody>
-      </p:sp>
-      <p:sp>
-        <p:nvSpPr>
-          <p:cNvPr name="TextBox 30" id="30"/>
-          <p:cNvSpPr txBox="true"/>
-          <p:nvPr/>
-        </p:nvSpPr>
-        <p:spPr>
-          <a:xfrm rot="0">
-            <a:off x="609600" y="5791200"/>
-            <a:ext cx="10972800" cy="393382"/>
-          </a:xfrm>
-          <a:prstGeom prst="rect">
-            <a:avLst/>
-          </a:prstGeom>
-        </p:spPr>
-        <p:txBody>
-          <a:bodyPr anchor="t" rtlCol="false" tIns="0" lIns="0" bIns="0" rIns="0">
-            <a:spAutoFit/>
-          </a:bodyPr>
-          <a:lstStyle/>
-          <a:p>
-            <a:pPr algn="ctr">
-              <a:lnSpc>
-                <a:spcPts val="3202"/>
-              </a:lnSpc>
-            </a:pPr>
-            <a:r>
-              <a:rPr lang="en-US" b="true" sz="2625">
-                <a:solidFill>
-                  <a:srgbClr val="151521"/>
-                </a:solidFill>
-                <a:latin typeface="DM Sans Bold"/>
-                <a:ea typeface="DM Sans Bold"/>
-                <a:cs typeface="DM Sans Bold"/>
-                <a:sym typeface="DM Sans Bold"/>
-              </a:rPr>
-              <a:t>The mistake points to the starting check.</a:t>
-            </a:r>
-          </a:p>
-        </p:txBody>
-      </p:sp>
-      <p:sp>
-        <p:nvSpPr>
-          <p:cNvPr name="AutoShape 31" id="31"/>
-          <p:cNvSpPr/>
-          <p:nvPr/>
-        </p:nvSpPr>
-        <p:spPr>
-          <a:xfrm>
-            <a:off x="609600" y="1381125"/>
-            <a:ext cx="10972800" cy="0"/>
-          </a:xfrm>
-          <a:prstGeom prst="line">
-            <a:avLst/>
-          </a:prstGeom>
-          <a:ln cap="flat" w="19050">
-            <a:solidFill>
-              <a:srgbClr val="CCD7E4"/>
-            </a:solidFill>
-            <a:prstDash val="solid"/>
-            <a:headEnd type="none" len="sm" w="sm"/>
-            <a:tailEnd type="none" len="sm" w="sm"/>
-          </a:ln>
-        </p:spPr>
+              <a:t>Return with fresh numbers</a:t>
+            </a:r>
+          </a:p>
+        </p:txBody>
       </p:sp>
     </p:spTree>
   </p:cSld>
@@ -19286,7 +19470,7 @@
                 <a:sym typeface="DM Sans"/>
                 <a:hlinkClick r:id="rId8" tooltip="https://backtrack-learning.vercel.app/demo"/>
               </a:rPr>
-              <a:t>backtrack-learning.vercel.app</a:t>
+              <a:t>backtrack-learning.vercel.app/demo</a:t>
             </a:r>
           </a:p>
         </p:txBody>

</xml_diff>